<commit_message>
docs(training): first-edition wording - no replacement or build-process traces
Slide and chapter heading 'Postman instead of curl' -> 'Calling the API with
Postman'; creation notes (newman results, 'while the course was built') removed
from learner-facing text; collection description reworded (requests and tests
unchanged). Both decks validate; 0 hits for the revision phrases in pptx text and md.

Co-Authored-By: Claude Opus 5.5 (1M context) <noreply@anthropic.com>
</commit_message>
<xml_diff>
--- a/docs/ai-agent-training/slides/lab-companion-lite.pptx
+++ b/docs/ai-agent-training/slides/lab-companion-lite.pptx
@@ -1325,7 +1325,7 @@
           <a:p>
             <a:r>
               <a:rPr lang="en-US" dirty="0"/>
-              <a:t>Covers full-track chapters 05 + 06. Cut for time: the separate envelope-discussion lab (chapter 05): the raw initialize below replaces it.</a:t>
+              <a:t>Covers full-track chapters 05 + 06. Cut for time: the separate envelope-discussion lab (chapter 05): the raw initialize below covers it.</a:t>
             </a:r>
             <a:endParaRPr lang="en-US" dirty="0"/>
           </a:p>
@@ -2821,7 +2821,7 @@
           <a:p>
             <a:r>
               <a:rPr lang="en-US" dirty="0"/>
-              <a:t>Verified with newman against the Docker stack: 24 requests, 0 failed, on a fresh database and again on a re-run; with a wrong password 17 assertions fail, so the tests can fail. The Inspector CLI (chapters 07 and 09) stays in the terminal on purpose: it is a real MCP client.</a:t>
+              <a:t>The Inspector CLI (chapters 07 and 09) stays in the terminal: it is a real MCP client, which is the point of those chapters.</a:t>
             </a:r>
             <a:endParaRPr lang="en-US" dirty="0"/>
           </a:p>
@@ -17573,7 +17573,7 @@
                   <a:srgbClr val="1B1F24"/>
                 </a:solidFill>
               </a:rPr>
-              <a:t>Postman instead of curl</a:t>
+              <a:t>Calling the API with Postman</a:t>
             </a:r>
             <a:endParaRPr lang="en-US" sz="3200" dirty="0"/>
           </a:p>

</xml_diff>

<commit_message>
docs(training): fence the SQLite error codes in the deck so its markdown stays prettier-stable
Co-Authored-By: Claude Opus 5.5 (1M context) <noreply@anthropic.com>
</commit_message>
<xml_diff>
--- a/docs/ai-agent-training/slides/lab-companion-lite.pptx
+++ b/docs/ai-agent-training/slides/lab-companion-lite.pptx
@@ -9414,7 +9414,57 @@
                   <a:srgbClr val="2B3440"/>
                 </a:solidFill>
               </a:rPr>
-              <a:t>A blocked delete reports SQLITE_CONSTRAINT_TRIGGER (RESTRICT) or …_FOREIGNKEY (NO ACTION). Map both to 409.</a:t>
+              <a:t>A blocked delete reports </a:t>
+            </a:r>
+            <a:pPr indent="0" marL="0">
+              <a:buNone/>
+            </a:pPr>
+            <a:r>
+              <a:rPr lang="en-US" sz="1400" dirty="0">
+                <a:solidFill>
+                  <a:srgbClr val="2B3440"/>
+                </a:solidFill>
+                <a:latin typeface="Courier New" pitchFamily="34" charset="0"/>
+                <a:ea typeface="Courier New" pitchFamily="34" charset="-122"/>
+                <a:cs typeface="Courier New" pitchFamily="34" charset="-120"/>
+              </a:rPr>
+              <a:t>SQLITE_CONSTRAINT_TRIGGER</a:t>
+            </a:r>
+            <a:pPr indent="0" marL="0">
+              <a:buNone/>
+            </a:pPr>
+            <a:r>
+              <a:rPr lang="en-US" sz="1400" dirty="0">
+                <a:solidFill>
+                  <a:srgbClr val="2B3440"/>
+                </a:solidFill>
+              </a:rPr>
+              <a:t> (RESTRICT) or </a:t>
+            </a:r>
+            <a:pPr indent="0" marL="0">
+              <a:buNone/>
+            </a:pPr>
+            <a:r>
+              <a:rPr lang="en-US" sz="1400" dirty="0">
+                <a:solidFill>
+                  <a:srgbClr val="2B3440"/>
+                </a:solidFill>
+                <a:latin typeface="Courier New" pitchFamily="34" charset="0"/>
+                <a:ea typeface="Courier New" pitchFamily="34" charset="-122"/>
+                <a:cs typeface="Courier New" pitchFamily="34" charset="-120"/>
+              </a:rPr>
+              <a:t>SQLITE_CONSTRAINT_FOREIGNKEY</a:t>
+            </a:r>
+            <a:pPr indent="0" marL="0">
+              <a:buNone/>
+            </a:pPr>
+            <a:r>
+              <a:rPr lang="en-US" sz="1400" dirty="0">
+                <a:solidFill>
+                  <a:srgbClr val="2B3440"/>
+                </a:solidFill>
+              </a:rPr>
+              <a:t> (NO ACTION). Map both to 409.</a:t>
             </a:r>
             <a:endParaRPr lang="en-US" sz="1600" dirty="0"/>
           </a:p>

</xml_diff>

<commit_message>
docs(training): rebuild the decks with the theme step; the slides README names it
Co-Authored-By: Claude Opus 5.5 (1M context) <noreply@anthropic.com>
</commit_message>
<xml_diff>
--- a/docs/ai-agent-training/slides/lab-companion-lite.pptx
+++ b/docs/ai-agent-training/slides/lab-companion-lite.pptx
@@ -22866,47 +22866,47 @@
 </file>
 
 <file path=ppt/theme/theme1.xml><?xml version="1.0" encoding="utf-8"?>
-<a:theme xmlns:a="http://schemas.openxmlformats.org/drawingml/2006/main" name="Office Theme">
+<a:theme xmlns:a="http://schemas.openxmlformats.org/drawingml/2006/main" name="Lab Companion">
   <a:themeElements>
-    <a:clrScheme name="Office">
+    <a:clrScheme name="Lab Companion">
       <a:dk1>
-        <a:sysClr val="windowText" lastClr="000000"/>
+        <a:srgbClr val="1B1F24"/>
       </a:dk1>
       <a:lt1>
-        <a:sysClr val="window" lastClr="FFFFFF"/>
+        <a:srgbClr val="FFFFFF"/>
       </a:lt1>
       <a:dk2>
-        <a:srgbClr val="44546A"/>
+        <a:srgbClr val="2B3440"/>
       </a:dk2>
       <a:lt2>
-        <a:srgbClr val="E7E6E6"/>
+        <a:srgbClr val="F1F5F9"/>
       </a:lt2>
       <a:accent1>
-        <a:srgbClr val="4472C4"/>
+        <a:srgbClr val="1FB68A"/>
       </a:accent1>
       <a:accent2>
-        <a:srgbClr val="ED7D31"/>
+        <a:srgbClr val="E69A28"/>
       </a:accent2>
       <a:accent3>
-        <a:srgbClr val="A5A5A5"/>
+        <a:srgbClr val="7C5CFF"/>
       </a:accent3>
       <a:accent4>
-        <a:srgbClr val="FFC000"/>
+        <a:srgbClr val="E5484D"/>
       </a:accent4>
       <a:accent5>
-        <a:srgbClr val="5B9BD5"/>
+        <a:srgbClr val="0F766E"/>
       </a:accent5>
       <a:accent6>
-        <a:srgbClr val="70AD47"/>
+        <a:srgbClr val="94A3B8"/>
       </a:accent6>
       <a:hlink>
-        <a:srgbClr val="0563C1"/>
+        <a:srgbClr val="0F766E"/>
       </a:hlink>
       <a:folHlink>
-        <a:srgbClr val="954F72"/>
+        <a:srgbClr val="7C5CFF"/>
       </a:folHlink>
     </a:clrScheme>
-    <a:fontScheme name="Office">
+    <a:fontScheme name="Lab Companion">
       <a:majorFont>
         <a:latin typeface="Calibri"/>
         <a:ea typeface=""/>

</xml_diff>